<commit_message>
Add SIH 2026 project final presentation
</commit_message>
<xml_diff>
--- a/SIH2026-IDEA-Presentation-Format.pptx
+++ b/SIH2026-IDEA-Presentation-Format.pptx
@@ -162,6 +162,51 @@
 </p:presentation>
 </file>
 
+<file path=ppt/changesInfos/changesInfo1.xml><?xml version="1.0" encoding="utf-8"?>
+<pc:chgInfo xmlns:a="http://schemas.openxmlformats.org/drawingml/2006/main" xmlns:r="http://schemas.openxmlformats.org/officeDocument/2006/relationships" xmlns:ac="http://schemas.microsoft.com/office/drawing/2013/main/command" xmlns:pc="http://schemas.microsoft.com/office/powerpoint/2013/main/command">
+  <pc:docChgLst>
+    <pc:chgData name="Sachin Mohite" userId="20c760fc03ba51e0" providerId="LiveId" clId="{B5FF31AA-4A80-44FD-B351-F7B4EE6E635B}"/>
+    <pc:docChg chg="custSel modSld">
+      <pc:chgData name="Sachin Mohite" userId="20c760fc03ba51e0" providerId="LiveId" clId="{B5FF31AA-4A80-44FD-B351-F7B4EE6E635B}" dt="2026-09-04T12:08:26.895" v="9" actId="478"/>
+      <pc:docMkLst>
+        <pc:docMk/>
+      </pc:docMkLst>
+      <pc:sldChg chg="addSp delSp modSp mod">
+        <pc:chgData name="Sachin Mohite" userId="20c760fc03ba51e0" providerId="LiveId" clId="{B5FF31AA-4A80-44FD-B351-F7B4EE6E635B}" dt="2026-09-04T12:08:26.895" v="9" actId="478"/>
+        <pc:sldMkLst>
+          <pc:docMk/>
+          <pc:sldMk cId="1588084416" sldId="297"/>
+        </pc:sldMkLst>
+        <pc:spChg chg="add del mod">
+          <ac:chgData name="Sachin Mohite" userId="20c760fc03ba51e0" providerId="LiveId" clId="{B5FF31AA-4A80-44FD-B351-F7B4EE6E635B}" dt="2026-09-04T12:08:24.733" v="6" actId="478"/>
+          <ac:spMkLst>
+            <pc:docMk/>
+            <pc:sldMk cId="1588084416" sldId="297"/>
+            <ac:spMk id="2" creationId="{78B0D16A-6ABB-BEB2-68FD-03A98C910C19}"/>
+          </ac:spMkLst>
+        </pc:spChg>
+        <pc:spChg chg="add del mod">
+          <ac:chgData name="Sachin Mohite" userId="20c760fc03ba51e0" providerId="LiveId" clId="{B5FF31AA-4A80-44FD-B351-F7B4EE6E635B}" dt="2026-09-04T12:08:24.735" v="8"/>
+          <ac:spMkLst>
+            <pc:docMk/>
+            <pc:sldMk cId="1588084416" sldId="297"/>
+            <ac:spMk id="8" creationId="{DE42C8E8-2EB7-8A17-81DE-F1BE88D325F4}"/>
+          </ac:spMkLst>
+        </pc:spChg>
+        <pc:spChg chg="add del">
+          <ac:chgData name="Sachin Mohite" userId="20c760fc03ba51e0" providerId="LiveId" clId="{B5FF31AA-4A80-44FD-B351-F7B4EE6E635B}" dt="2026-09-04T12:08:26.895" v="9" actId="478"/>
+          <ac:spMkLst>
+            <pc:docMk/>
+            <pc:sldMk cId="1588084416" sldId="297"/>
+            <ac:spMk id="9" creationId="{1D921429-995A-ED32-3004-031BC646A53B}"/>
+          </ac:spMkLst>
+        </pc:spChg>
+      </pc:sldChg>
+    </pc:docChg>
+  </pc:docChgLst>
+</pc:chgInfo>
+</file>
+
 <file path=ppt/notesMasters/notesMaster1.xml><?xml version="1.0" encoding="utf-8"?>
 <p:notesMaster xmlns:a="http://schemas.openxmlformats.org/drawingml/2006/main" xmlns:r="http://schemas.openxmlformats.org/officeDocument/2006/relationships" xmlns:p="http://schemas.openxmlformats.org/presentationml/2006/main">
   <p:cSld>
@@ -262,7 +307,7 @@
             <a:fld id="{C4D5ADD5-2BBC-4A94-8F86-D9013941F742}" type="datetimeFigureOut">
               <a:rPr lang="en-US"/>
               <a:pPr/>
-              <a:t>6/2/2026</a:t>
+              <a:t>9/4/2026</a:t>
             </a:fld>
             <a:endParaRPr lang="en-US"/>
           </a:p>
@@ -1713,7 +1758,7 @@
           <a:p>
             <a:fld id="{E60792E3-D524-454C-8AFD-A91972900BCB}" type="datetime1">
               <a:rPr lang="en-US" smtClean="0"/>
-              <a:t>6/2/2026</a:t>
+              <a:t>9/4/2026</a:t>
             </a:fld>
             <a:endParaRPr lang="en-US"/>
           </a:p>
@@ -1895,7 +1940,7 @@
           <a:p>
             <a:fld id="{053C3A68-6922-42D3-8905-ECC2D82A3469}" type="datetime1">
               <a:rPr lang="en-US" smtClean="0"/>
-              <a:t>6/2/2026</a:t>
+              <a:t>9/4/2026</a:t>
             </a:fld>
             <a:endParaRPr lang="en-US"/>
           </a:p>
@@ -2087,7 +2132,7 @@
           <a:p>
             <a:fld id="{CB69E9F4-7604-4950-A8B2-8ACDEDB1506E}" type="datetime1">
               <a:rPr lang="en-US" smtClean="0"/>
-              <a:t>6/2/2026</a:t>
+              <a:t>9/4/2026</a:t>
             </a:fld>
             <a:endParaRPr lang="en-US"/>
           </a:p>
@@ -2269,7 +2314,7 @@
           <a:p>
             <a:fld id="{708B7524-32A2-4C20-A58C-BC3BAA1042FC}" type="datetime1">
               <a:rPr lang="en-US" smtClean="0"/>
-              <a:t>6/2/2026</a:t>
+              <a:t>9/4/2026</a:t>
             </a:fld>
             <a:endParaRPr lang="en-US"/>
           </a:p>
@@ -2528,7 +2573,7 @@
           <a:p>
             <a:fld id="{1E994447-D6B2-43BB-A877-57F1A267B999}" type="datetime1">
               <a:rPr lang="en-US" smtClean="0"/>
-              <a:t>6/2/2026</a:t>
+              <a:t>9/4/2026</a:t>
             </a:fld>
             <a:endParaRPr lang="en-US"/>
           </a:p>
@@ -2827,7 +2872,7 @@
           <a:p>
             <a:fld id="{68920E16-BD35-483C-AA6B-346FC7E46DEA}" type="datetime1">
               <a:rPr lang="en-US" smtClean="0"/>
-              <a:t>6/2/2026</a:t>
+              <a:t>9/4/2026</a:t>
             </a:fld>
             <a:endParaRPr lang="en-US"/>
           </a:p>
@@ -3260,7 +3305,7 @@
           <a:p>
             <a:fld id="{2FEAC6F8-5103-4FC0-A69E-5C6AE6469DA8}" type="datetime1">
               <a:rPr lang="en-US" smtClean="0"/>
-              <a:t>6/2/2026</a:t>
+              <a:t>9/4/2026</a:t>
             </a:fld>
             <a:endParaRPr lang="en-US"/>
           </a:p>
@@ -3391,7 +3436,7 @@
           <a:p>
             <a:fld id="{C60C6921-0627-4C8F-83D5-0CF936D2FFDD}" type="datetime1">
               <a:rPr lang="en-US" smtClean="0"/>
-              <a:t>6/2/2026</a:t>
+              <a:t>9/4/2026</a:t>
             </a:fld>
             <a:endParaRPr lang="en-US"/>
           </a:p>
@@ -3500,7 +3545,7 @@
           <a:p>
             <a:fld id="{2FF08AD7-8103-40F8-983C-E2BA6BB9CBE0}" type="datetime1">
               <a:rPr lang="en-US" smtClean="0"/>
-              <a:t>6/2/2026</a:t>
+              <a:t>9/4/2026</a:t>
             </a:fld>
             <a:endParaRPr lang="en-US"/>
           </a:p>
@@ -3789,7 +3834,7 @@
           <a:p>
             <a:fld id="{DF8C06B4-9380-4A4D-AF49-A3596E17DAF5}" type="datetime1">
               <a:rPr lang="en-US" smtClean="0"/>
-              <a:t>6/2/2026</a:t>
+              <a:t>9/4/2026</a:t>
             </a:fld>
             <a:endParaRPr lang="en-US"/>
           </a:p>
@@ -4058,7 +4103,7 @@
           <a:p>
             <a:fld id="{EF7FDEF1-C582-4E22-9E77-D68326471F28}" type="datetime1">
               <a:rPr lang="en-US" smtClean="0"/>
-              <a:t>6/2/2026</a:t>
+              <a:t>9/4/2026</a:t>
             </a:fld>
             <a:endParaRPr lang="en-US"/>
           </a:p>
@@ -4301,7 +4346,7 @@
           <a:p>
             <a:fld id="{780A9602-A9A9-453F-AEF1-37B5837E02CD}" type="datetime1">
               <a:rPr lang="en-US" smtClean="0"/>
-              <a:t>6/2/2026</a:t>
+              <a:t>9/4/2026</a:t>
             </a:fld>
             <a:endParaRPr lang="en-US"/>
           </a:p>
@@ -4852,7 +4897,7 @@
                 <a16:creationId xmlns:a16="http://schemas.microsoft.com/office/drawing/2014/main" id="{3E443FD7-A66B-4AA0-872D-B088B9BC5F17}"/>
               </a:ext>
               <a:ext uri="{C183D7F6-B498-43B3-948B-1728B52AA6E4}">
-                <adec:decorative xmlns:adec="http://schemas.microsoft.com/office/drawing/2017/decorative" xmlns="" val="1"/>
+                <adec:decorative xmlns:adec="http://schemas.microsoft.com/office/drawing/2017/decorative" val="1"/>
               </a:ext>
             </a:extLst>
           </p:cNvPr>
@@ -4912,7 +4957,7 @@
                 <a16:creationId xmlns:a16="http://schemas.microsoft.com/office/drawing/2014/main" id="{C04BE0EF-3561-49B4-9A29-F283168A91C7}"/>
               </a:ext>
               <a:ext uri="{C183D7F6-B498-43B3-948B-1728B52AA6E4}">
-                <adec:decorative xmlns:adec="http://schemas.microsoft.com/office/drawing/2017/decorative" xmlns="" val="1"/>
+                <adec:decorative xmlns:adec="http://schemas.microsoft.com/office/drawing/2017/decorative" val="1"/>
               </a:ext>
             </a:extLst>
           </p:cNvPr>
@@ -5783,16 +5828,7 @@
                 </a:solidFill>
                 <a:latin typeface="Garamond" panose="02020404030301010803" pitchFamily="18" charset="0"/>
               </a:rPr>
-              <a:t>SMART INDIA HACKATHON </a:t>
-            </a:r>
-            <a:r>
-              <a:rPr lang="en-US" sz="4000" b="1" dirty="0" smtClean="0">
-                <a:solidFill>
-                  <a:schemeClr val="tx2"/>
-                </a:solidFill>
-                <a:latin typeface="Garamond" panose="02020404030301010803" pitchFamily="18" charset="0"/>
-              </a:rPr>
-              <a:t>2026</a:t>
+              <a:t>SMART INDIA HACKATHON 2026</a:t>
             </a:r>
             <a:endParaRPr lang="en-IN" sz="4000" b="1" dirty="0">
               <a:solidFill>
@@ -6063,14 +6099,6 @@
           <a:lstStyle/>
           <a:p>
             <a:pPr eaLnBrk="1" hangingPunct="1"/>
-            <a:r>
-              <a:rPr lang="en-US" sz="3600" b="1" dirty="0">
-                <a:latin typeface="Times New Roman" panose="02020603050405020304" pitchFamily="18" charset="0"/>
-                <a:ea typeface="ＭＳ Ｐゴシック" pitchFamily="1" charset="-128"/>
-                <a:cs typeface="Times New Roman" panose="02020603050405020304" pitchFamily="18" charset="0"/>
-              </a:rPr>
-              <a:t/>
-            </a:r>
             <a:br>
               <a:rPr lang="en-US" sz="3600" b="1" dirty="0">
                 <a:latin typeface="Times New Roman" panose="02020603050405020304" pitchFamily="18" charset="0"/>
@@ -6287,7 +6315,7 @@
                 <a16:creationId xmlns:a16="http://schemas.microsoft.com/office/drawing/2014/main" id="{5DBCE864-823D-4A13-9607-5DA1F0ED5FB8}"/>
               </a:ext>
               <a:ext uri="{C183D7F6-B498-43B3-948B-1728B52AA6E4}">
-                <adec:decorative xmlns:adec="http://schemas.microsoft.com/office/drawing/2017/decorative" xmlns="" val="0"/>
+                <adec:decorative xmlns:adec="http://schemas.microsoft.com/office/drawing/2017/decorative" val="0"/>
               </a:ext>
             </a:extLst>
           </p:cNvPr>
@@ -6612,7 +6640,7 @@
                 <a16:creationId xmlns:a16="http://schemas.microsoft.com/office/drawing/2014/main" id="{5DBCE864-823D-4A13-9607-5DA1F0ED5FB8}"/>
               </a:ext>
               <a:ext uri="{C183D7F6-B498-43B3-948B-1728B52AA6E4}">
-                <adec:decorative xmlns:adec="http://schemas.microsoft.com/office/drawing/2017/decorative" xmlns="" val="0"/>
+                <adec:decorative xmlns:adec="http://schemas.microsoft.com/office/drawing/2017/decorative" val="0"/>
               </a:ext>
             </a:extLst>
           </p:cNvPr>
@@ -7148,7 +7176,7 @@
                 <a16:creationId xmlns:a16="http://schemas.microsoft.com/office/drawing/2014/main" id="{5DBCE864-823D-4A13-9607-5DA1F0ED5FB8}"/>
               </a:ext>
               <a:ext uri="{C183D7F6-B498-43B3-948B-1728B52AA6E4}">
-                <adec:decorative xmlns:adec="http://schemas.microsoft.com/office/drawing/2017/decorative" xmlns="" val="0"/>
+                <adec:decorative xmlns:adec="http://schemas.microsoft.com/office/drawing/2017/decorative" val="0"/>
               </a:ext>
             </a:extLst>
           </p:cNvPr>
@@ -7615,7 +7643,7 @@
                 <a16:creationId xmlns:a16="http://schemas.microsoft.com/office/drawing/2014/main" id="{5DBCE864-823D-4A13-9607-5DA1F0ED5FB8}"/>
               </a:ext>
               <a:ext uri="{C183D7F6-B498-43B3-948B-1728B52AA6E4}">
-                <adec:decorative xmlns:adec="http://schemas.microsoft.com/office/drawing/2017/decorative" xmlns="" val="0"/>
+                <adec:decorative xmlns:adec="http://schemas.microsoft.com/office/drawing/2017/decorative" val="0"/>
               </a:ext>
             </a:extLst>
           </p:cNvPr>
@@ -8060,7 +8088,7 @@
                 <a16:creationId xmlns:a16="http://schemas.microsoft.com/office/drawing/2014/main" id="{5DBCE864-823D-4A13-9607-5DA1F0ED5FB8}"/>
               </a:ext>
               <a:ext uri="{C183D7F6-B498-43B3-948B-1728B52AA6E4}">
-                <adec:decorative xmlns:adec="http://schemas.microsoft.com/office/drawing/2017/decorative" xmlns="" val="0"/>
+                <adec:decorative xmlns:adec="http://schemas.microsoft.com/office/drawing/2017/decorative" val="0"/>
               </a:ext>
             </a:extLst>
           </p:cNvPr>

</xml_diff>